<commit_message>
Fix empty pitch-deck .pptx: seed reference slide so slides register
build_pptx in branding.py created the pandoc reference deck with zero slides, so
its presentation.xml had no <p:sldIdLst>. Pandoc only repopulates an existing
slide-ID list, so converted decks shipped with 10 slide parts but none registered,
opening empty in PowerPoint / Google Slides.

Seed one blank slide in the reference deck. Pandoc rebuilds the list from converted
content, so the placeholder is not carried into output.

Verified: both decks now register 10 slides (python-pptx reads 10, was 0), no leftover
placeholder, dash scan still 0.

Fixes #10

Co-Authored-By: Claude Opus 4.8 (1M context) <noreply@anthropic.com>
</commit_message>
<xml_diff>
--- a/sales-templates/en/eduasiste-pitch-deck.pptx
+++ b/sales-templates/en/eduasiste-pitch-deck.pptx
@@ -7,6 +7,18 @@
   <p:notesMasterIdLst>
     <p:notesMasterId r:id="rId12"/>
   </p:notesMasterIdLst>
+  <p:sldIdLst>
+    <p:sldId id="256" r:id="rId2"/>
+    <p:sldId id="257" r:id="rId3"/>
+    <p:sldId id="258" r:id="rId4"/>
+    <p:sldId id="259" r:id="rId5"/>
+    <p:sldId id="260" r:id="rId6"/>
+    <p:sldId id="261" r:id="rId7"/>
+    <p:sldId id="262" r:id="rId8"/>
+    <p:sldId id="263" r:id="rId9"/>
+    <p:sldId id="264" r:id="rId10"/>
+    <p:sldId id="265" r:id="rId11"/>
+  </p:sldIdLst>
   <p:sldSz cx="12191695" cy="6858000" type="screen4x3"/>
   <p:notesSz cx="6858000" cy="9144000"/>
   <p:defaultTextStyle>

</xml_diff>